<commit_message>
Update Fall Menu assets with new images
</commit_message>
<xml_diff>
--- a/Assets/Menu/FallMenu/Menu.pptx
+++ b/Assets/Menu/FallMenu/Menu.pptx
@@ -12011,10 +12011,10 @@
       </p:sp>
       <p:pic>
         <p:nvPicPr>
-          <p:cNvPr id="14" name="Picture 13">
+          <p:cNvPr id="12" name="Picture 11">
             <a:extLst>
               <a:ext uri="{FF2B5EF4-FFF2-40B4-BE49-F238E27FC236}">
-                <a16:creationId xmlns:a16="http://schemas.microsoft.com/office/drawing/2014/main" id="{83DFFE28-0DC2-C292-2CB4-E35F1617BED8}"/>
+                <a16:creationId xmlns:a16="http://schemas.microsoft.com/office/drawing/2014/main" id="{9F943202-F9F6-A7FD-9FB8-A7EB88EE3007}"/>
               </a:ext>
             </a:extLst>
           </p:cNvPr>
@@ -12031,7 +12031,7 @@
         </p:blipFill>
         <p:spPr>
           <a:xfrm>
-            <a:off x="6094752" y="-484192"/>
+            <a:off x="6094792" y="-530503"/>
             <a:ext cx="6093184" cy="6093184"/>
           </a:xfrm>
           <a:prstGeom prst="rect">

</xml_diff>